<commit_message>
decks: add operating model principles slide (slide 3)
Four principles of the new lakehouse operating model:
  01 Platform builds the highway — Business drives on it
  02 One truth, two surfaces — no exceptions
  03 Governed by design, not by approval
  04 Migration is complete when Business confirms parity

2x2 grid, colour-coded by principle number (blue/teal/purple/green).
Appended as slide 3 to raci-exec-r.pptx.
</commit_message>
<xml_diff>
--- a/decks/raci-exec-r.pptx
+++ b/decks/raci-exec-r.pptx
@@ -7,9 +7,10 @@
   <p:sldIdLst>
     <p:sldId id="256" r:id="rId2"/>
     <p:sldId id="257" r:id="rId3"/>
+    <p:sldId id="258" r:id="rId4"/>
   </p:sldIdLst>
   <p:notesMasterIdLst>
-    <p:notesMasterId r:id="rId4"/>
+    <p:notesMasterId r:id="rId5"/>
   </p:notesMasterIdLst>
   <p:sldSz cx="12188952" cy="6858000"/>
   <p:notesSz cx="6858000" cy="12188952"/>
@@ -633,6 +634,94 @@
 </p:notes>
 </file>
 
+<file path=ppt/notesSlides/notesSlide3.xml><?xml version="1.0" encoding="utf-8"?>
+<p:notes xmlns:a="http://schemas.openxmlformats.org/drawingml/2006/main" xmlns:r="http://schemas.openxmlformats.org/officeDocument/2006/relationships" xmlns:p="http://schemas.openxmlformats.org/presentationml/2006/main">
+  <p:cSld>
+    <p:spTree>
+      <p:nvGrpSpPr>
+        <p:cNvPr id="1" name=""/>
+        <p:cNvGrpSpPr/>
+        <p:nvPr/>
+      </p:nvGrpSpPr>
+      <p:grpSpPr>
+        <a:xfrm>
+          <a:off x="0" y="0"/>
+          <a:ext cx="0" cy="0"/>
+          <a:chOff x="0" y="0"/>
+          <a:chExt cx="0" cy="0"/>
+        </a:xfrm>
+      </p:grpSpPr>
+      <p:sp>
+        <p:nvSpPr>
+          <p:cNvPr id="2" name="Slide Image Placeholder 1"/>
+          <p:cNvSpPr>
+            <a:spLocks noGrp="1" noRot="1" noChangeAspect="1"/>
+          </p:cNvSpPr>
+          <p:nvPr>
+            <p:ph type="sldImg"/>
+          </p:nvPr>
+        </p:nvSpPr>
+        <p:spPr/>
+      </p:sp>
+      <p:sp>
+        <p:nvSpPr>
+          <p:cNvPr id="3" name="Notes Placeholder 2"/>
+          <p:cNvSpPr>
+            <a:spLocks noGrp="1"/>
+          </p:cNvSpPr>
+          <p:nvPr>
+            <p:ph type="body" idx="1"/>
+          </p:nvPr>
+        </p:nvSpPr>
+        <p:spPr/>
+        <p:txBody>
+          <a:bodyPr/>
+          <a:lstStyle/>
+          <a:p>
+            <a:r>
+              <a:rPr lang="en-US" dirty="0"/>
+              <a:t/>
+            </a:r>
+            <a:endParaRPr lang="en-US" dirty="0"/>
+          </a:p>
+        </p:txBody>
+      </p:sp>
+      <p:sp>
+        <p:nvSpPr>
+          <p:cNvPr id="4" name="Slide Number Placeholder 3"/>
+          <p:cNvSpPr>
+            <a:spLocks noGrp="1"/>
+          </p:cNvSpPr>
+          <p:nvPr>
+            <p:ph type="sldNum" sz="quarter" idx="10"/>
+          </p:nvPr>
+        </p:nvSpPr>
+        <p:spPr/>
+        <p:txBody>
+          <a:bodyPr/>
+          <a:lstStyle/>
+          <a:p>
+            <a:fld id="{F7021451-1387-4CA6-816F-3879F97B5CBC}" type="slidenum">
+              <a:rPr lang="en-US"/>
+              <a:t>3</a:t>
+            </a:fld>
+            <a:endParaRPr lang="en-US"/>
+          </a:p>
+        </p:txBody>
+      </p:sp>
+    </p:spTree>
+    <p:extLst>
+      <p:ext uri="{BB962C8B-B14F-4D97-AF65-F5344CB8AC3E}">
+        <p14:creationId xmlns:p14="http://schemas.microsoft.com/office/powerpoint/2010/main" val="1024086991"/>
+      </p:ext>
+    </p:extLst>
+  </p:cSld>
+  <p:clrMapOvr>
+    <a:masterClrMapping/>
+  </p:clrMapOvr>
+</p:notes>
+</file>
+
 <file path=ppt/slideLayouts/slideLayout1.xml><?xml version="1.0" encoding="utf-8"?>
 <p:sldLayout xmlns:a="http://schemas.openxmlformats.org/drawingml/2006/main" xmlns:r="http://schemas.openxmlformats.org/officeDocument/2006/relationships" xmlns:p="http://schemas.openxmlformats.org/presentationml/2006/main" preserve="1">
   <p:cSld name="DEFAULT">
@@ -6325,6 +6414,1279 @@
               <a:t>Full responsibility matrix (59 activities): chilakos.github.io/lakehouse/governance/responsibility-matrix.html</a:t>
             </a:r>
             <a:endParaRPr lang="en-US" sz="750" dirty="0"/>
+          </a:p>
+        </p:txBody>
+      </p:sp>
+    </p:spTree>
+  </p:cSld>
+  <p:clrMapOvr>
+    <a:masterClrMapping/>
+  </p:clrMapOvr>
+</p:sld>
+</file>
+
+<file path=ppt/slides/slide3.xml><?xml version="1.0" encoding="utf-8"?>
+<p:sld xmlns:a="http://schemas.openxmlformats.org/drawingml/2006/main" xmlns:r="http://schemas.openxmlformats.org/officeDocument/2006/relationships" xmlns:p="http://schemas.openxmlformats.org/presentationml/2006/main">
+  <p:cSld name="Slide 3">
+    <p:bg>
+      <p:bgPr>
+        <a:solidFill>
+          <a:srgbClr val="FFFFFF"/>
+        </a:solidFill>
+      </p:bgPr>
+    </p:bg>
+    <p:spTree>
+      <p:nvGrpSpPr>
+        <p:cNvPr id="1" name=""/>
+        <p:cNvGrpSpPr/>
+        <p:nvPr/>
+      </p:nvGrpSpPr>
+      <p:grpSpPr>
+        <a:xfrm>
+          <a:off x="0" y="0"/>
+          <a:ext cx="0" cy="0"/>
+          <a:chOff x="0" y="0"/>
+          <a:chExt cx="0" cy="0"/>
+        </a:xfrm>
+      </p:grpSpPr>
+      <p:sp>
+        <p:nvSpPr>
+          <p:cNvPr id="2" name="Shape 0"/>
+          <p:cNvSpPr/>
+          <p:nvPr/>
+        </p:nvSpPr>
+        <p:spPr>
+          <a:xfrm>
+            <a:off x="0" y="0"/>
+            <a:ext cx="12188952" cy="237744"/>
+          </a:xfrm>
+          <a:prstGeom prst="rect">
+            <a:avLst/>
+          </a:prstGeom>
+          <a:solidFill>
+            <a:srgbClr val="F3F4FB"/>
+          </a:solidFill>
+          <a:ln w="12700">
+            <a:solidFill>
+              <a:srgbClr val="F3F4FB"/>
+            </a:solidFill>
+            <a:prstDash val="solid"/>
+          </a:ln>
+        </p:spPr>
+      </p:sp>
+      <p:sp>
+        <p:nvSpPr>
+          <p:cNvPr id="3" name="Text 1"/>
+          <p:cNvSpPr/>
+          <p:nvPr/>
+        </p:nvSpPr>
+        <p:spPr>
+          <a:xfrm>
+            <a:off x="274320" y="36576"/>
+            <a:ext cx="5486400" cy="164592"/>
+          </a:xfrm>
+          <a:prstGeom prst="rect">
+            <a:avLst/>
+          </a:prstGeom>
+          <a:noFill/>
+          <a:ln/>
+        </p:spPr>
+        <p:txBody>
+          <a:bodyPr wrap="square" rtlCol="0" anchor="ctr"/>
+          <a:lstStyle/>
+          <a:p>
+            <a:pPr indent="0" marL="0">
+              <a:buNone/>
+            </a:pPr>
+            <a:r>
+              <a:rPr lang="en-US" sz="700" dirty="0">
+                <a:solidFill>
+                  <a:srgbClr val="87AFBF"/>
+                </a:solidFill>
+                <a:latin typeface="Arial" pitchFamily="34" charset="0"/>
+                <a:ea typeface="Arial" pitchFamily="34" charset="-122"/>
+                <a:cs typeface="Arial" pitchFamily="34" charset="-120"/>
+              </a:rPr>
+              <a:t>Confidential — Internal Use Only</a:t>
+            </a:r>
+            <a:endParaRPr lang="en-US" sz="700" dirty="0"/>
+          </a:p>
+        </p:txBody>
+      </p:sp>
+      <p:sp>
+        <p:nvSpPr>
+          <p:cNvPr id="4" name="Text 2"/>
+          <p:cNvSpPr/>
+          <p:nvPr/>
+        </p:nvSpPr>
+        <p:spPr>
+          <a:xfrm>
+            <a:off x="8778240" y="36576"/>
+            <a:ext cx="3200400" cy="164592"/>
+          </a:xfrm>
+          <a:prstGeom prst="rect">
+            <a:avLst/>
+          </a:prstGeom>
+          <a:noFill/>
+          <a:ln/>
+        </p:spPr>
+        <p:txBody>
+          <a:bodyPr wrap="square" rtlCol="0" anchor="ctr"/>
+          <a:lstStyle/>
+          <a:p>
+            <a:pPr algn="r" indent="0" marL="0">
+              <a:buNone/>
+            </a:pPr>
+            <a:r>
+              <a:rPr lang="en-US" sz="700" dirty="0">
+                <a:solidFill>
+                  <a:srgbClr val="87AFBF"/>
+                </a:solidFill>
+                <a:latin typeface="Arial" pitchFamily="34" charset="0"/>
+                <a:ea typeface="Arial" pitchFamily="34" charset="-122"/>
+                <a:cs typeface="Arial" pitchFamily="34" charset="-120"/>
+              </a:rPr>
+              <a:t>Lumina · RBC Enterprise Data</a:t>
+            </a:r>
+            <a:endParaRPr lang="en-US" sz="700" dirty="0"/>
+          </a:p>
+        </p:txBody>
+      </p:sp>
+      <p:sp>
+        <p:nvSpPr>
+          <p:cNvPr id="5" name="Text 3"/>
+          <p:cNvSpPr/>
+          <p:nvPr/>
+        </p:nvSpPr>
+        <p:spPr>
+          <a:xfrm>
+            <a:off x="11704320" y="6629400"/>
+            <a:ext cx="365760" cy="182880"/>
+          </a:xfrm>
+          <a:prstGeom prst="rect">
+            <a:avLst/>
+          </a:prstGeom>
+          <a:noFill/>
+          <a:ln/>
+        </p:spPr>
+        <p:txBody>
+          <a:bodyPr wrap="square" rtlCol="0" anchor="ctr"/>
+          <a:lstStyle/>
+          <a:p>
+            <a:pPr algn="r" indent="0" marL="0">
+              <a:buNone/>
+            </a:pPr>
+            <a:r>
+              <a:rPr lang="en-US" sz="800" dirty="0">
+                <a:solidFill>
+                  <a:srgbClr val="87AFBF"/>
+                </a:solidFill>
+                <a:latin typeface="Arial" pitchFamily="34" charset="0"/>
+                <a:ea typeface="Arial" pitchFamily="34" charset="-122"/>
+                <a:cs typeface="Arial" pitchFamily="34" charset="-120"/>
+              </a:rPr>
+              <a:t>3</a:t>
+            </a:r>
+            <a:endParaRPr lang="en-US" sz="800" dirty="0"/>
+          </a:p>
+        </p:txBody>
+      </p:sp>
+      <p:sp>
+        <p:nvSpPr>
+          <p:cNvPr id="6" name="Text 4"/>
+          <p:cNvSpPr/>
+          <p:nvPr/>
+        </p:nvSpPr>
+        <p:spPr>
+          <a:xfrm>
+            <a:off x="365760" y="310896"/>
+            <a:ext cx="11430000" cy="457200"/>
+          </a:xfrm>
+          <a:prstGeom prst="rect">
+            <a:avLst/>
+          </a:prstGeom>
+          <a:noFill/>
+          <a:ln/>
+        </p:spPr>
+        <p:txBody>
+          <a:bodyPr wrap="square" rtlCol="0" anchor="ctr"/>
+          <a:lstStyle/>
+          <a:p>
+            <a:pPr indent="0" marL="0">
+              <a:buNone/>
+            </a:pPr>
+            <a:r>
+              <a:rPr lang="en-US" sz="2200" b="1" dirty="0">
+                <a:solidFill>
+                  <a:srgbClr val="003068"/>
+                </a:solidFill>
+                <a:latin typeface="Arial" pitchFamily="34" charset="0"/>
+                <a:ea typeface="Arial" pitchFamily="34" charset="-122"/>
+                <a:cs typeface="Arial" pitchFamily="34" charset="-120"/>
+              </a:rPr>
+              <a:t>Principles of the New Lakehouse Operating Model</a:t>
+            </a:r>
+            <a:endParaRPr lang="en-US" sz="2200" dirty="0"/>
+          </a:p>
+        </p:txBody>
+      </p:sp>
+      <p:sp>
+        <p:nvSpPr>
+          <p:cNvPr id="7" name="Text 5"/>
+          <p:cNvSpPr/>
+          <p:nvPr/>
+        </p:nvSpPr>
+        <p:spPr>
+          <a:xfrm>
+            <a:off x="365760" y="768096"/>
+            <a:ext cx="11430000" cy="219456"/>
+          </a:xfrm>
+          <a:prstGeom prst="rect">
+            <a:avLst/>
+          </a:prstGeom>
+          <a:noFill/>
+          <a:ln/>
+        </p:spPr>
+        <p:txBody>
+          <a:bodyPr wrap="square" rtlCol="0" anchor="ctr"/>
+          <a:lstStyle/>
+          <a:p>
+            <a:pPr indent="0" marL="0">
+              <a:buNone/>
+            </a:pPr>
+            <a:r>
+              <a:rPr lang="en-US" sz="1000" i="1" dirty="0">
+                <a:solidFill>
+                  <a:srgbClr val="64748B"/>
+                </a:solidFill>
+                <a:latin typeface="Arial" pitchFamily="34" charset="0"/>
+                <a:ea typeface="Arial" pitchFamily="34" charset="-122"/>
+                <a:cs typeface="Arial" pitchFamily="34" charset="-120"/>
+              </a:rPr>
+              <a:t>The non-negotiable behaviours that define how Platform, DMO and Business work together</a:t>
+            </a:r>
+            <a:endParaRPr lang="en-US" sz="1000" dirty="0"/>
+          </a:p>
+        </p:txBody>
+      </p:sp>
+      <p:sp>
+        <p:nvSpPr>
+          <p:cNvPr id="8" name="Shape 6"/>
+          <p:cNvSpPr/>
+          <p:nvPr/>
+        </p:nvSpPr>
+        <p:spPr>
+          <a:xfrm>
+            <a:off x="365760" y="1005840"/>
+            <a:ext cx="11457432" cy="20117"/>
+          </a:xfrm>
+          <a:prstGeom prst="rect">
+            <a:avLst/>
+          </a:prstGeom>
+          <a:solidFill>
+            <a:srgbClr val="87AFBF"/>
+          </a:solidFill>
+          <a:ln w="12700">
+            <a:solidFill>
+              <a:srgbClr val="87AFBF"/>
+            </a:solidFill>
+            <a:prstDash val="solid"/>
+          </a:ln>
+        </p:spPr>
+      </p:sp>
+      <p:sp>
+        <p:nvSpPr>
+          <p:cNvPr id="9" name="Shape 7"/>
+          <p:cNvSpPr/>
+          <p:nvPr/>
+        </p:nvSpPr>
+        <p:spPr>
+          <a:xfrm>
+            <a:off x="320040" y="1115568"/>
+            <a:ext cx="5577840" cy="2606040"/>
+          </a:xfrm>
+          <a:prstGeom prst="rect">
+            <a:avLst>
+              <a:gd name="adj" fmla="val 3509"/>
+            </a:avLst>
+          </a:prstGeom>
+          <a:solidFill>
+            <a:srgbClr val="EFF6FF"/>
+          </a:solidFill>
+          <a:ln w="12700">
+            <a:solidFill>
+              <a:srgbClr val="BFDBFE"/>
+            </a:solidFill>
+            <a:prstDash val="solid"/>
+          </a:ln>
+        </p:spPr>
+      </p:sp>
+      <p:sp>
+        <p:nvSpPr>
+          <p:cNvPr id="10" name="Shape 8"/>
+          <p:cNvSpPr/>
+          <p:nvPr/>
+        </p:nvSpPr>
+        <p:spPr>
+          <a:xfrm>
+            <a:off x="320040" y="1115568"/>
+            <a:ext cx="5577840" cy="54864"/>
+          </a:xfrm>
+          <a:prstGeom prst="rect">
+            <a:avLst>
+              <a:gd name="adj" fmla="val 166667"/>
+            </a:avLst>
+          </a:prstGeom>
+          <a:solidFill>
+            <a:srgbClr val="3068FF"/>
+          </a:solidFill>
+          <a:ln w="12700">
+            <a:solidFill>
+              <a:srgbClr val="3068FF"/>
+            </a:solidFill>
+            <a:prstDash val="solid"/>
+          </a:ln>
+        </p:spPr>
+      </p:sp>
+      <p:sp>
+        <p:nvSpPr>
+          <p:cNvPr id="11" name="Shape 9"/>
+          <p:cNvSpPr/>
+          <p:nvPr/>
+        </p:nvSpPr>
+        <p:spPr>
+          <a:xfrm>
+            <a:off x="320040" y="1143000"/>
+            <a:ext cx="5577840" cy="54864"/>
+          </a:xfrm>
+          <a:prstGeom prst="rect">
+            <a:avLst/>
+          </a:prstGeom>
+          <a:solidFill>
+            <a:srgbClr val="3068FF"/>
+          </a:solidFill>
+          <a:ln w="12700">
+            <a:solidFill>
+              <a:srgbClr val="3068FF"/>
+            </a:solidFill>
+            <a:prstDash val="solid"/>
+          </a:ln>
+        </p:spPr>
+      </p:sp>
+      <p:sp>
+        <p:nvSpPr>
+          <p:cNvPr id="12" name="Shape 10"/>
+          <p:cNvSpPr/>
+          <p:nvPr/>
+        </p:nvSpPr>
+        <p:spPr>
+          <a:xfrm>
+            <a:off x="484632" y="1252728"/>
+            <a:ext cx="475488" cy="475488"/>
+          </a:xfrm>
+          <a:prstGeom prst="ellipse">
+            <a:avLst/>
+          </a:prstGeom>
+          <a:solidFill>
+            <a:srgbClr val="3068FF"/>
+          </a:solidFill>
+          <a:ln w="12700">
+            <a:solidFill>
+              <a:srgbClr val="3068FF"/>
+            </a:solidFill>
+            <a:prstDash val="solid"/>
+          </a:ln>
+        </p:spPr>
+      </p:sp>
+      <p:sp>
+        <p:nvSpPr>
+          <p:cNvPr id="13" name="Text 11"/>
+          <p:cNvSpPr/>
+          <p:nvPr/>
+        </p:nvSpPr>
+        <p:spPr>
+          <a:xfrm>
+            <a:off x="484632" y="1252728"/>
+            <a:ext cx="475488" cy="475488"/>
+          </a:xfrm>
+          <a:prstGeom prst="rect">
+            <a:avLst/>
+          </a:prstGeom>
+          <a:noFill/>
+          <a:ln/>
+        </p:spPr>
+        <p:txBody>
+          <a:bodyPr wrap="square" lIns="0" tIns="0" rIns="0" bIns="0" rtlCol="0" anchor="ctr"/>
+          <a:lstStyle/>
+          <a:p>
+            <a:pPr algn="ctr" indent="0" marL="0">
+              <a:buNone/>
+            </a:pPr>
+            <a:r>
+              <a:rPr lang="en-US" sz="1200" b="1" dirty="0">
+                <a:solidFill>
+                  <a:srgbClr val="FFFFFF"/>
+                </a:solidFill>
+                <a:latin typeface="Arial" pitchFamily="34" charset="0"/>
+                <a:ea typeface="Arial" pitchFamily="34" charset="-122"/>
+                <a:cs typeface="Arial" pitchFamily="34" charset="-120"/>
+              </a:rPr>
+              <a:t>01</a:t>
+            </a:r>
+            <a:endParaRPr lang="en-US" sz="1200" dirty="0"/>
+          </a:p>
+        </p:txBody>
+      </p:sp>
+      <p:sp>
+        <p:nvSpPr>
+          <p:cNvPr id="14" name="Text 12"/>
+          <p:cNvSpPr/>
+          <p:nvPr/>
+        </p:nvSpPr>
+        <p:spPr>
+          <a:xfrm>
+            <a:off x="1069848" y="1243584"/>
+            <a:ext cx="4663440" cy="512064"/>
+          </a:xfrm>
+          <a:prstGeom prst="rect">
+            <a:avLst/>
+          </a:prstGeom>
+          <a:noFill/>
+          <a:ln/>
+        </p:spPr>
+        <p:txBody>
+          <a:bodyPr wrap="square" lIns="0" tIns="0" rIns="0" bIns="0" rtlCol="0" anchor="ctr"/>
+          <a:lstStyle/>
+          <a:p>
+            <a:pPr indent="0" marL="0">
+              <a:buNone/>
+            </a:pPr>
+            <a:r>
+              <a:rPr lang="en-US" sz="1200" b="1" dirty="0">
+                <a:solidFill>
+                  <a:srgbClr val="3068FF"/>
+                </a:solidFill>
+                <a:latin typeface="Arial" pitchFamily="34" charset="0"/>
+                <a:ea typeface="Arial" pitchFamily="34" charset="-122"/>
+                <a:cs typeface="Arial" pitchFamily="34" charset="-120"/>
+              </a:rPr>
+              <a:t>Platform builds the highway — Business drives on it</a:t>
+            </a:r>
+            <a:endParaRPr lang="en-US" sz="1200" dirty="0"/>
+          </a:p>
+        </p:txBody>
+      </p:sp>
+      <p:sp>
+        <p:nvSpPr>
+          <p:cNvPr id="15" name="Shape 13"/>
+          <p:cNvSpPr/>
+          <p:nvPr/>
+        </p:nvSpPr>
+        <p:spPr>
+          <a:xfrm>
+            <a:off x="484632" y="1828800"/>
+            <a:ext cx="5248656" cy="18288"/>
+          </a:xfrm>
+          <a:prstGeom prst="rect">
+            <a:avLst/>
+          </a:prstGeom>
+          <a:solidFill>
+            <a:srgbClr val="BFDBFE"/>
+          </a:solidFill>
+          <a:ln w="12700">
+            <a:solidFill>
+              <a:srgbClr val="BFDBFE"/>
+            </a:solidFill>
+            <a:prstDash val="solid"/>
+          </a:ln>
+        </p:spPr>
+      </p:sp>
+      <p:sp>
+        <p:nvSpPr>
+          <p:cNvPr id="16" name="Text 14"/>
+          <p:cNvSpPr/>
+          <p:nvPr/>
+        </p:nvSpPr>
+        <p:spPr>
+          <a:xfrm>
+            <a:off x="484632" y="1920240"/>
+            <a:ext cx="5248656" cy="1636776"/>
+          </a:xfrm>
+          <a:prstGeom prst="rect">
+            <a:avLst/>
+          </a:prstGeom>
+          <a:noFill/>
+          <a:ln/>
+        </p:spPr>
+        <p:txBody>
+          <a:bodyPr wrap="square" rtlCol="0" anchor="t"/>
+          <a:lstStyle/>
+          <a:p>
+            <a:pPr indent="0" marL="0">
+              <a:lnSpc>
+                <a:spcPct val="120000"/>
+              </a:lnSpc>
+              <a:buNone/>
+            </a:pPr>
+            <a:r>
+              <a:rPr lang="en-US" sz="900" dirty="0">
+                <a:solidFill>
+                  <a:srgbClr val="222730"/>
+                </a:solidFill>
+                <a:latin typeface="Arial" pitchFamily="34" charset="0"/>
+                <a:ea typeface="Arial" pitchFamily="34" charset="-122"/>
+                <a:cs typeface="Arial" pitchFamily="34" charset="-120"/>
+              </a:rPr>
+              <a:t>The Platform Team is responsible for infrastructure, pipelines, and the technical framework. Business and DMO are responsible for what the data means, whether it is correct, and when legacy systems can be retired. Blurring this boundary — Platform self-certifying migrations, or Business directing engineering decisions — is the most common failure mode in platform programmes.</a:t>
+            </a:r>
+            <a:endParaRPr lang="en-US" sz="900" dirty="0"/>
+          </a:p>
+        </p:txBody>
+      </p:sp>
+      <p:sp>
+        <p:nvSpPr>
+          <p:cNvPr id="17" name="Shape 15"/>
+          <p:cNvSpPr/>
+          <p:nvPr/>
+        </p:nvSpPr>
+        <p:spPr>
+          <a:xfrm>
+            <a:off x="6163056" y="1115568"/>
+            <a:ext cx="5577840" cy="2606040"/>
+          </a:xfrm>
+          <a:prstGeom prst="rect">
+            <a:avLst>
+              <a:gd name="adj" fmla="val 3509"/>
+            </a:avLst>
+          </a:prstGeom>
+          <a:solidFill>
+            <a:srgbClr val="ECFEFF"/>
+          </a:solidFill>
+          <a:ln w="12700">
+            <a:solidFill>
+              <a:srgbClr val="A5F3FC"/>
+            </a:solidFill>
+            <a:prstDash val="solid"/>
+          </a:ln>
+        </p:spPr>
+      </p:sp>
+      <p:sp>
+        <p:nvSpPr>
+          <p:cNvPr id="18" name="Shape 16"/>
+          <p:cNvSpPr/>
+          <p:nvPr/>
+        </p:nvSpPr>
+        <p:spPr>
+          <a:xfrm>
+            <a:off x="6163056" y="1115568"/>
+            <a:ext cx="5577840" cy="54864"/>
+          </a:xfrm>
+          <a:prstGeom prst="rect">
+            <a:avLst>
+              <a:gd name="adj" fmla="val 166667"/>
+            </a:avLst>
+          </a:prstGeom>
+          <a:solidFill>
+            <a:srgbClr val="0891B2"/>
+          </a:solidFill>
+          <a:ln w="12700">
+            <a:solidFill>
+              <a:srgbClr val="0891B2"/>
+            </a:solidFill>
+            <a:prstDash val="solid"/>
+          </a:ln>
+        </p:spPr>
+      </p:sp>
+      <p:sp>
+        <p:nvSpPr>
+          <p:cNvPr id="19" name="Shape 17"/>
+          <p:cNvSpPr/>
+          <p:nvPr/>
+        </p:nvSpPr>
+        <p:spPr>
+          <a:xfrm>
+            <a:off x="6163056" y="1143000"/>
+            <a:ext cx="5577840" cy="54864"/>
+          </a:xfrm>
+          <a:prstGeom prst="rect">
+            <a:avLst/>
+          </a:prstGeom>
+          <a:solidFill>
+            <a:srgbClr val="0891B2"/>
+          </a:solidFill>
+          <a:ln w="12700">
+            <a:solidFill>
+              <a:srgbClr val="0891B2"/>
+            </a:solidFill>
+            <a:prstDash val="solid"/>
+          </a:ln>
+        </p:spPr>
+      </p:sp>
+      <p:sp>
+        <p:nvSpPr>
+          <p:cNvPr id="20" name="Shape 18"/>
+          <p:cNvSpPr/>
+          <p:nvPr/>
+        </p:nvSpPr>
+        <p:spPr>
+          <a:xfrm>
+            <a:off x="6327648" y="1252728"/>
+            <a:ext cx="475488" cy="475488"/>
+          </a:xfrm>
+          <a:prstGeom prst="ellipse">
+            <a:avLst/>
+          </a:prstGeom>
+          <a:solidFill>
+            <a:srgbClr val="0891B2"/>
+          </a:solidFill>
+          <a:ln w="12700">
+            <a:solidFill>
+              <a:srgbClr val="0891B2"/>
+            </a:solidFill>
+            <a:prstDash val="solid"/>
+          </a:ln>
+        </p:spPr>
+      </p:sp>
+      <p:sp>
+        <p:nvSpPr>
+          <p:cNvPr id="21" name="Text 19"/>
+          <p:cNvSpPr/>
+          <p:nvPr/>
+        </p:nvSpPr>
+        <p:spPr>
+          <a:xfrm>
+            <a:off x="6327648" y="1252728"/>
+            <a:ext cx="475488" cy="475488"/>
+          </a:xfrm>
+          <a:prstGeom prst="rect">
+            <a:avLst/>
+          </a:prstGeom>
+          <a:noFill/>
+          <a:ln/>
+        </p:spPr>
+        <p:txBody>
+          <a:bodyPr wrap="square" lIns="0" tIns="0" rIns="0" bIns="0" rtlCol="0" anchor="ctr"/>
+          <a:lstStyle/>
+          <a:p>
+            <a:pPr algn="ctr" indent="0" marL="0">
+              <a:buNone/>
+            </a:pPr>
+            <a:r>
+              <a:rPr lang="en-US" sz="1200" b="1" dirty="0">
+                <a:solidFill>
+                  <a:srgbClr val="FFFFFF"/>
+                </a:solidFill>
+                <a:latin typeface="Arial" pitchFamily="34" charset="0"/>
+                <a:ea typeface="Arial" pitchFamily="34" charset="-122"/>
+                <a:cs typeface="Arial" pitchFamily="34" charset="-120"/>
+              </a:rPr>
+              <a:t>02</a:t>
+            </a:r>
+            <a:endParaRPr lang="en-US" sz="1200" dirty="0"/>
+          </a:p>
+        </p:txBody>
+      </p:sp>
+      <p:sp>
+        <p:nvSpPr>
+          <p:cNvPr id="22" name="Text 20"/>
+          <p:cNvSpPr/>
+          <p:nvPr/>
+        </p:nvSpPr>
+        <p:spPr>
+          <a:xfrm>
+            <a:off x="6912864" y="1243584"/>
+            <a:ext cx="4663440" cy="512064"/>
+          </a:xfrm>
+          <a:prstGeom prst="rect">
+            <a:avLst/>
+          </a:prstGeom>
+          <a:noFill/>
+          <a:ln/>
+        </p:spPr>
+        <p:txBody>
+          <a:bodyPr wrap="square" lIns="0" tIns="0" rIns="0" bIns="0" rtlCol="0" anchor="ctr"/>
+          <a:lstStyle/>
+          <a:p>
+            <a:pPr indent="0" marL="0">
+              <a:buNone/>
+            </a:pPr>
+            <a:r>
+              <a:rPr lang="en-US" sz="1200" b="1" dirty="0">
+                <a:solidFill>
+                  <a:srgbClr val="0891B2"/>
+                </a:solidFill>
+                <a:latin typeface="Arial" pitchFamily="34" charset="0"/>
+                <a:ea typeface="Arial" pitchFamily="34" charset="-122"/>
+                <a:cs typeface="Arial" pitchFamily="34" charset="-120"/>
+              </a:rPr>
+              <a:t>One truth, two surfaces — no exceptions</a:t>
+            </a:r>
+            <a:endParaRPr lang="en-US" sz="1200" dirty="0"/>
+          </a:p>
+        </p:txBody>
+      </p:sp>
+      <p:sp>
+        <p:nvSpPr>
+          <p:cNvPr id="23" name="Shape 21"/>
+          <p:cNvSpPr/>
+          <p:nvPr/>
+        </p:nvSpPr>
+        <p:spPr>
+          <a:xfrm>
+            <a:off x="6327648" y="1828800"/>
+            <a:ext cx="5248656" cy="18288"/>
+          </a:xfrm>
+          <a:prstGeom prst="rect">
+            <a:avLst/>
+          </a:prstGeom>
+          <a:solidFill>
+            <a:srgbClr val="A5F3FC"/>
+          </a:solidFill>
+          <a:ln w="12700">
+            <a:solidFill>
+              <a:srgbClr val="A5F3FC"/>
+            </a:solidFill>
+            <a:prstDash val="solid"/>
+          </a:ln>
+        </p:spPr>
+      </p:sp>
+      <p:sp>
+        <p:nvSpPr>
+          <p:cNvPr id="24" name="Text 22"/>
+          <p:cNvSpPr/>
+          <p:nvPr/>
+        </p:nvSpPr>
+        <p:spPr>
+          <a:xfrm>
+            <a:off x="6327648" y="1920240"/>
+            <a:ext cx="5248656" cy="1636776"/>
+          </a:xfrm>
+          <a:prstGeom prst="rect">
+            <a:avLst/>
+          </a:prstGeom>
+          <a:noFill/>
+          <a:ln/>
+        </p:spPr>
+        <p:txBody>
+          <a:bodyPr wrap="square" rtlCol="0" anchor="t"/>
+          <a:lstStyle/>
+          <a:p>
+            <a:pPr indent="0" marL="0">
+              <a:lnSpc>
+                <a:spcPct val="120000"/>
+              </a:lnSpc>
+              <a:buNone/>
+            </a:pPr>
+            <a:r>
+              <a:rPr lang="en-US" sz="900" dirty="0">
+                <a:solidFill>
+                  <a:srgbClr val="222730"/>
+                </a:solidFill>
+                <a:latin typeface="Arial" pitchFamily="34" charset="0"/>
+                <a:ea typeface="Arial" pitchFamily="34" charset="-122"/>
+                <a:cs typeface="Arial" pitchFamily="34" charset="-120"/>
+              </a:rPr>
+              <a:t>Gold Iceberg on-prem is the single authoritative data source. Fabric provides the BI and AI surface; Trino provides the compute surface. Every number — Power BI dashboard, RBC Assist AI answer, Tableau report, or regulatory submission — traces to the same Gold table, the same transformation logic, and the same lineage path. Domain-specific data stores that diverge from Gold are not permitted.</a:t>
+            </a:r>
+            <a:endParaRPr lang="en-US" sz="900" dirty="0"/>
+          </a:p>
+        </p:txBody>
+      </p:sp>
+      <p:sp>
+        <p:nvSpPr>
+          <p:cNvPr id="25" name="Shape 23"/>
+          <p:cNvSpPr/>
+          <p:nvPr/>
+        </p:nvSpPr>
+        <p:spPr>
+          <a:xfrm>
+            <a:off x="320040" y="3913632"/>
+            <a:ext cx="5577840" cy="2606040"/>
+          </a:xfrm>
+          <a:prstGeom prst="rect">
+            <a:avLst>
+              <a:gd name="adj" fmla="val 3509"/>
+            </a:avLst>
+          </a:prstGeom>
+          <a:solidFill>
+            <a:srgbClr val="FAF5FF"/>
+          </a:solidFill>
+          <a:ln w="12700">
+            <a:solidFill>
+              <a:srgbClr val="DDD6FE"/>
+            </a:solidFill>
+            <a:prstDash val="solid"/>
+          </a:ln>
+        </p:spPr>
+      </p:sp>
+      <p:sp>
+        <p:nvSpPr>
+          <p:cNvPr id="26" name="Shape 24"/>
+          <p:cNvSpPr/>
+          <p:nvPr/>
+        </p:nvSpPr>
+        <p:spPr>
+          <a:xfrm>
+            <a:off x="320040" y="3913632"/>
+            <a:ext cx="5577840" cy="54864"/>
+          </a:xfrm>
+          <a:prstGeom prst="rect">
+            <a:avLst>
+              <a:gd name="adj" fmla="val 166667"/>
+            </a:avLst>
+          </a:prstGeom>
+          <a:solidFill>
+            <a:srgbClr val="4C1D95"/>
+          </a:solidFill>
+          <a:ln w="12700">
+            <a:solidFill>
+              <a:srgbClr val="4C1D95"/>
+            </a:solidFill>
+            <a:prstDash val="solid"/>
+          </a:ln>
+        </p:spPr>
+      </p:sp>
+      <p:sp>
+        <p:nvSpPr>
+          <p:cNvPr id="27" name="Shape 25"/>
+          <p:cNvSpPr/>
+          <p:nvPr/>
+        </p:nvSpPr>
+        <p:spPr>
+          <a:xfrm>
+            <a:off x="320040" y="3941064"/>
+            <a:ext cx="5577840" cy="54864"/>
+          </a:xfrm>
+          <a:prstGeom prst="rect">
+            <a:avLst/>
+          </a:prstGeom>
+          <a:solidFill>
+            <a:srgbClr val="4C1D95"/>
+          </a:solidFill>
+          <a:ln w="12700">
+            <a:solidFill>
+              <a:srgbClr val="4C1D95"/>
+            </a:solidFill>
+            <a:prstDash val="solid"/>
+          </a:ln>
+        </p:spPr>
+      </p:sp>
+      <p:sp>
+        <p:nvSpPr>
+          <p:cNvPr id="28" name="Shape 26"/>
+          <p:cNvSpPr/>
+          <p:nvPr/>
+        </p:nvSpPr>
+        <p:spPr>
+          <a:xfrm>
+            <a:off x="484632" y="4050792"/>
+            <a:ext cx="475488" cy="475488"/>
+          </a:xfrm>
+          <a:prstGeom prst="ellipse">
+            <a:avLst/>
+          </a:prstGeom>
+          <a:solidFill>
+            <a:srgbClr val="4C1D95"/>
+          </a:solidFill>
+          <a:ln w="12700">
+            <a:solidFill>
+              <a:srgbClr val="4C1D95"/>
+            </a:solidFill>
+            <a:prstDash val="solid"/>
+          </a:ln>
+        </p:spPr>
+      </p:sp>
+      <p:sp>
+        <p:nvSpPr>
+          <p:cNvPr id="29" name="Text 27"/>
+          <p:cNvSpPr/>
+          <p:nvPr/>
+        </p:nvSpPr>
+        <p:spPr>
+          <a:xfrm>
+            <a:off x="484632" y="4050792"/>
+            <a:ext cx="475488" cy="475488"/>
+          </a:xfrm>
+          <a:prstGeom prst="rect">
+            <a:avLst/>
+          </a:prstGeom>
+          <a:noFill/>
+          <a:ln/>
+        </p:spPr>
+        <p:txBody>
+          <a:bodyPr wrap="square" lIns="0" tIns="0" rIns="0" bIns="0" rtlCol="0" anchor="ctr"/>
+          <a:lstStyle/>
+          <a:p>
+            <a:pPr algn="ctr" indent="0" marL="0">
+              <a:buNone/>
+            </a:pPr>
+            <a:r>
+              <a:rPr lang="en-US" sz="1200" b="1" dirty="0">
+                <a:solidFill>
+                  <a:srgbClr val="FFFFFF"/>
+                </a:solidFill>
+                <a:latin typeface="Arial" pitchFamily="34" charset="0"/>
+                <a:ea typeface="Arial" pitchFamily="34" charset="-122"/>
+                <a:cs typeface="Arial" pitchFamily="34" charset="-120"/>
+              </a:rPr>
+              <a:t>03</a:t>
+            </a:r>
+            <a:endParaRPr lang="en-US" sz="1200" dirty="0"/>
+          </a:p>
+        </p:txBody>
+      </p:sp>
+      <p:sp>
+        <p:nvSpPr>
+          <p:cNvPr id="30" name="Text 28"/>
+          <p:cNvSpPr/>
+          <p:nvPr/>
+        </p:nvSpPr>
+        <p:spPr>
+          <a:xfrm>
+            <a:off x="1069848" y="4041648"/>
+            <a:ext cx="4663440" cy="512064"/>
+          </a:xfrm>
+          <a:prstGeom prst="rect">
+            <a:avLst/>
+          </a:prstGeom>
+          <a:noFill/>
+          <a:ln/>
+        </p:spPr>
+        <p:txBody>
+          <a:bodyPr wrap="square" lIns="0" tIns="0" rIns="0" bIns="0" rtlCol="0" anchor="ctr"/>
+          <a:lstStyle/>
+          <a:p>
+            <a:pPr indent="0" marL="0">
+              <a:buNone/>
+            </a:pPr>
+            <a:r>
+              <a:rPr lang="en-US" sz="1200" b="1" dirty="0">
+                <a:solidFill>
+                  <a:srgbClr val="4C1D95"/>
+                </a:solidFill>
+                <a:latin typeface="Arial" pitchFamily="34" charset="0"/>
+                <a:ea typeface="Arial" pitchFamily="34" charset="-122"/>
+                <a:cs typeface="Arial" pitchFamily="34" charset="-120"/>
+              </a:rPr>
+              <a:t>Governed by design, not by approval</a:t>
+            </a:r>
+            <a:endParaRPr lang="en-US" sz="1200" dirty="0"/>
+          </a:p>
+        </p:txBody>
+      </p:sp>
+      <p:sp>
+        <p:nvSpPr>
+          <p:cNvPr id="31" name="Shape 29"/>
+          <p:cNvSpPr/>
+          <p:nvPr/>
+        </p:nvSpPr>
+        <p:spPr>
+          <a:xfrm>
+            <a:off x="484632" y="4626864"/>
+            <a:ext cx="5248656" cy="18288"/>
+          </a:xfrm>
+          <a:prstGeom prst="rect">
+            <a:avLst/>
+          </a:prstGeom>
+          <a:solidFill>
+            <a:srgbClr val="DDD6FE"/>
+          </a:solidFill>
+          <a:ln w="12700">
+            <a:solidFill>
+              <a:srgbClr val="DDD6FE"/>
+            </a:solidFill>
+            <a:prstDash val="solid"/>
+          </a:ln>
+        </p:spPr>
+      </p:sp>
+      <p:sp>
+        <p:nvSpPr>
+          <p:cNvPr id="32" name="Text 30"/>
+          <p:cNvSpPr/>
+          <p:nvPr/>
+        </p:nvSpPr>
+        <p:spPr>
+          <a:xfrm>
+            <a:off x="484632" y="4718304"/>
+            <a:ext cx="5248656" cy="1636776"/>
+          </a:xfrm>
+          <a:prstGeom prst="rect">
+            <a:avLst/>
+          </a:prstGeom>
+          <a:noFill/>
+          <a:ln/>
+        </p:spPr>
+        <p:txBody>
+          <a:bodyPr wrap="square" rtlCol="0" anchor="t"/>
+          <a:lstStyle/>
+          <a:p>
+            <a:pPr indent="0" marL="0">
+              <a:lnSpc>
+                <a:spcPct val="120000"/>
+              </a:lnSpc>
+              <a:buNone/>
+            </a:pPr>
+            <a:r>
+              <a:rPr lang="en-US" sz="900" dirty="0">
+                <a:solidFill>
+                  <a:srgbClr val="222730"/>
+                </a:solidFill>
+                <a:latin typeface="Arial" pitchFamily="34" charset="0"/>
+                <a:ea typeface="Arial" pitchFamily="34" charset="-122"/>
+                <a:cs typeface="Arial" pitchFamily="34" charset="-120"/>
+              </a:rPr>
+              <a:t>Security masking, data quality gates, and column-level lineage are embedded in the pipeline framework — not applied after delivery. A new table is automatically classified and default-denied when it lands in Bronze. Compliance is structural: if it can be bypassed, it is not a control. The cost of building governance in later is ten times the cost of building it in now.</a:t>
+            </a:r>
+            <a:endParaRPr lang="en-US" sz="900" dirty="0"/>
+          </a:p>
+        </p:txBody>
+      </p:sp>
+      <p:sp>
+        <p:nvSpPr>
+          <p:cNvPr id="33" name="Shape 31"/>
+          <p:cNvSpPr/>
+          <p:nvPr/>
+        </p:nvSpPr>
+        <p:spPr>
+          <a:xfrm>
+            <a:off x="6163056" y="3913632"/>
+            <a:ext cx="5577840" cy="2606040"/>
+          </a:xfrm>
+          <a:prstGeom prst="rect">
+            <a:avLst>
+              <a:gd name="adj" fmla="val 3509"/>
+            </a:avLst>
+          </a:prstGeom>
+          <a:solidFill>
+            <a:srgbClr val="ECFDF5"/>
+          </a:solidFill>
+          <a:ln w="12700">
+            <a:solidFill>
+              <a:srgbClr val="A7F3D0"/>
+            </a:solidFill>
+            <a:prstDash val="solid"/>
+          </a:ln>
+        </p:spPr>
+      </p:sp>
+      <p:sp>
+        <p:nvSpPr>
+          <p:cNvPr id="34" name="Shape 32"/>
+          <p:cNvSpPr/>
+          <p:nvPr/>
+        </p:nvSpPr>
+        <p:spPr>
+          <a:xfrm>
+            <a:off x="6163056" y="3913632"/>
+            <a:ext cx="5577840" cy="54864"/>
+          </a:xfrm>
+          <a:prstGeom prst="rect">
+            <a:avLst>
+              <a:gd name="adj" fmla="val 166667"/>
+            </a:avLst>
+          </a:prstGeom>
+          <a:solidFill>
+            <a:srgbClr val="059669"/>
+          </a:solidFill>
+          <a:ln w="12700">
+            <a:solidFill>
+              <a:srgbClr val="059669"/>
+            </a:solidFill>
+            <a:prstDash val="solid"/>
+          </a:ln>
+        </p:spPr>
+      </p:sp>
+      <p:sp>
+        <p:nvSpPr>
+          <p:cNvPr id="35" name="Shape 33"/>
+          <p:cNvSpPr/>
+          <p:nvPr/>
+        </p:nvSpPr>
+        <p:spPr>
+          <a:xfrm>
+            <a:off x="6163056" y="3941064"/>
+            <a:ext cx="5577840" cy="54864"/>
+          </a:xfrm>
+          <a:prstGeom prst="rect">
+            <a:avLst/>
+          </a:prstGeom>
+          <a:solidFill>
+            <a:srgbClr val="059669"/>
+          </a:solidFill>
+          <a:ln w="12700">
+            <a:solidFill>
+              <a:srgbClr val="059669"/>
+            </a:solidFill>
+            <a:prstDash val="solid"/>
+          </a:ln>
+        </p:spPr>
+      </p:sp>
+      <p:sp>
+        <p:nvSpPr>
+          <p:cNvPr id="36" name="Shape 34"/>
+          <p:cNvSpPr/>
+          <p:nvPr/>
+        </p:nvSpPr>
+        <p:spPr>
+          <a:xfrm>
+            <a:off x="6327648" y="4050792"/>
+            <a:ext cx="475488" cy="475488"/>
+          </a:xfrm>
+          <a:prstGeom prst="ellipse">
+            <a:avLst/>
+          </a:prstGeom>
+          <a:solidFill>
+            <a:srgbClr val="059669"/>
+          </a:solidFill>
+          <a:ln w="12700">
+            <a:solidFill>
+              <a:srgbClr val="059669"/>
+            </a:solidFill>
+            <a:prstDash val="solid"/>
+          </a:ln>
+        </p:spPr>
+      </p:sp>
+      <p:sp>
+        <p:nvSpPr>
+          <p:cNvPr id="37" name="Text 35"/>
+          <p:cNvSpPr/>
+          <p:nvPr/>
+        </p:nvSpPr>
+        <p:spPr>
+          <a:xfrm>
+            <a:off x="6327648" y="4050792"/>
+            <a:ext cx="475488" cy="475488"/>
+          </a:xfrm>
+          <a:prstGeom prst="rect">
+            <a:avLst/>
+          </a:prstGeom>
+          <a:noFill/>
+          <a:ln/>
+        </p:spPr>
+        <p:txBody>
+          <a:bodyPr wrap="square" lIns="0" tIns="0" rIns="0" bIns="0" rtlCol="0" anchor="ctr"/>
+          <a:lstStyle/>
+          <a:p>
+            <a:pPr algn="ctr" indent="0" marL="0">
+              <a:buNone/>
+            </a:pPr>
+            <a:r>
+              <a:rPr lang="en-US" sz="1200" b="1" dirty="0">
+                <a:solidFill>
+                  <a:srgbClr val="FFFFFF"/>
+                </a:solidFill>
+                <a:latin typeface="Arial" pitchFamily="34" charset="0"/>
+                <a:ea typeface="Arial" pitchFamily="34" charset="-122"/>
+                <a:cs typeface="Arial" pitchFamily="34" charset="-120"/>
+              </a:rPr>
+              <a:t>04</a:t>
+            </a:r>
+            <a:endParaRPr lang="en-US" sz="1200" dirty="0"/>
+          </a:p>
+        </p:txBody>
+      </p:sp>
+      <p:sp>
+        <p:nvSpPr>
+          <p:cNvPr id="38" name="Text 36"/>
+          <p:cNvSpPr/>
+          <p:nvPr/>
+        </p:nvSpPr>
+        <p:spPr>
+          <a:xfrm>
+            <a:off x="6912864" y="4041648"/>
+            <a:ext cx="4663440" cy="512064"/>
+          </a:xfrm>
+          <a:prstGeom prst="rect">
+            <a:avLst/>
+          </a:prstGeom>
+          <a:noFill/>
+          <a:ln/>
+        </p:spPr>
+        <p:txBody>
+          <a:bodyPr wrap="square" lIns="0" tIns="0" rIns="0" bIns="0" rtlCol="0" anchor="ctr"/>
+          <a:lstStyle/>
+          <a:p>
+            <a:pPr indent="0" marL="0">
+              <a:buNone/>
+            </a:pPr>
+            <a:r>
+              <a:rPr lang="en-US" sz="1200" b="1" dirty="0">
+                <a:solidFill>
+                  <a:srgbClr val="059669"/>
+                </a:solidFill>
+                <a:latin typeface="Arial" pitchFamily="34" charset="0"/>
+                <a:ea typeface="Arial" pitchFamily="34" charset="-122"/>
+                <a:cs typeface="Arial" pitchFamily="34" charset="-120"/>
+              </a:rPr>
+              <a:t>Migration is complete when Business confirms parity</a:t>
+            </a:r>
+            <a:endParaRPr lang="en-US" sz="1200" dirty="0"/>
+          </a:p>
+        </p:txBody>
+      </p:sp>
+      <p:sp>
+        <p:nvSpPr>
+          <p:cNvPr id="39" name="Shape 37"/>
+          <p:cNvSpPr/>
+          <p:nvPr/>
+        </p:nvSpPr>
+        <p:spPr>
+          <a:xfrm>
+            <a:off x="6327648" y="4626864"/>
+            <a:ext cx="5248656" cy="18288"/>
+          </a:xfrm>
+          <a:prstGeom prst="rect">
+            <a:avLst/>
+          </a:prstGeom>
+          <a:solidFill>
+            <a:srgbClr val="A7F3D0"/>
+          </a:solidFill>
+          <a:ln w="12700">
+            <a:solidFill>
+              <a:srgbClr val="A7F3D0"/>
+            </a:solidFill>
+            <a:prstDash val="solid"/>
+          </a:ln>
+        </p:spPr>
+      </p:sp>
+      <p:sp>
+        <p:nvSpPr>
+          <p:cNvPr id="40" name="Text 38"/>
+          <p:cNvSpPr/>
+          <p:nvPr/>
+        </p:nvSpPr>
+        <p:spPr>
+          <a:xfrm>
+            <a:off x="6327648" y="4718304"/>
+            <a:ext cx="5248656" cy="1636776"/>
+          </a:xfrm>
+          <a:prstGeom prst="rect">
+            <a:avLst/>
+          </a:prstGeom>
+          <a:noFill/>
+          <a:ln/>
+        </p:spPr>
+        <p:txBody>
+          <a:bodyPr wrap="square" rtlCol="0" anchor="t"/>
+          <a:lstStyle/>
+          <a:p>
+            <a:pPr indent="0" marL="0">
+              <a:lnSpc>
+                <a:spcPct val="120000"/>
+              </a:lnSpc>
+              <a:buNone/>
+            </a:pPr>
+            <a:r>
+              <a:rPr lang="en-US" sz="900" dirty="0">
+                <a:solidFill>
+                  <a:srgbClr val="222730"/>
+                </a:solidFill>
+                <a:latin typeface="Arial" pitchFamily="34" charset="0"/>
+                <a:ea typeface="Arial" pitchFamily="34" charset="-122"/>
+                <a:cs typeface="Arial" pitchFamily="34" charset="-120"/>
+              </a:rPr>
+              <a:t>The Platform Team cannot self-certify a migration. DataStage jobs are not retired until Business validates that new Python pipelines produce identical output. Teradata tables are not decommissioned until Business confirms no downstream consumer — including manual queries, scheduled extracts, and spreadsheet feeds — depends on them. No platform team unilaterally declares a legacy system safe to switch off.</a:t>
+            </a:r>
+            <a:endParaRPr lang="en-US" sz="900" dirty="0"/>
           </a:p>
         </p:txBody>
       </p:sp>

</xml_diff>